<commit_message>
docs: update presentation with post-MVP features, trial-and-error entries #09-#16, and design decisions Q7-Q10
Slides updated: Key Features (layout-aware ingest, batch, title, LLM intent), Agent Pipeline (Supervisor v1->v2, RAG Phase 0-5), Design Decisions (Q7-Q10), Trial & Error (#09-#16)

Ultraworked with Sisyphus

Co-authored-by: Sisyphus <clio-agent@sisyphuslabs.ai>
</commit_message>
<xml_diff>
--- a/Research_Agent_Final_Presentation.pptx
+++ b/Research_Agent_Final_Presentation.pptx
@@ -8292,23 +8292,14 @@
               </a:defRPr>
             </a:pPr>
             <a:r>
-              <a:t>PyMuPDF → Chunk → BGE-m3 → FAISS</a:t>
-            </a:r>
-          </a:p>
-          <a:p>
-            <a:pPr algn="ctr">
-              <a:spcAft>
-                <a:spcPts val="400"/>
-              </a:spcAft>
-              <a:defRPr sz="1300" b="0">
+              <a:rPr sz="1100">
                 <a:solidFill>
                   <a:srgbClr val="333333"/>
                 </a:solidFill>
-                <a:latin typeface="Calibri"/>
-              </a:defRPr>
-            </a:pPr>
-            <a:r>
-              <a:t>자동 임베딩 및 인덱싱</a:t>
+              </a:rPr>
+              <a:t>PyMuPDF4LLM → Layout Markdown → BGE-m3 → FAISS
+Layout-aware (다단/표), OCR 자동 fallback,
+파일 다중 업로드 (batch ingest), 제목 자동 추출</a:t>
             </a:r>
           </a:p>
         </p:txBody>
@@ -8428,23 +8419,14 @@
               </a:defRPr>
             </a:pPr>
             <a:r>
-              <a:t>Langchain RetrievalQA</a:t>
-            </a:r>
-          </a:p>
-          <a:p>
-            <a:pPr algn="ctr">
-              <a:spcAft>
-                <a:spcPts val="400"/>
-              </a:spcAft>
-              <a:defRPr sz="1300" b="0">
+              <a:rPr sz="1100">
                 <a:solidFill>
                   <a:srgbClr val="333333"/>
                 </a:solidFill>
-                <a:latin typeface="Calibri"/>
-              </a:defRPr>
-            </a:pPr>
-            <a:r>
-              <a:t>+ Ollama LLM + Source Citation</a:t>
+              </a:rPr>
+              <a:t>Langchain RetrievalQA + Ollama + Source Citation
+Semantic Chunking, Query Rewriting,
+Multi-Strategy Retrieval (HyDE + RRF)</a:t>
             </a:r>
           </a:p>
         </p:txBody>
@@ -8564,23 +8546,14 @@
               </a:defRPr>
             </a:pPr>
             <a:r>
-              <a:t>Supervisor → Paper / Arxiv / Report</a:t>
-            </a:r>
-          </a:p>
-          <a:p>
-            <a:pPr algn="ctr">
-              <a:spcAft>
-                <a:spcPts val="400"/>
-              </a:spcAft>
-              <a:defRPr sz="1300" b="0">
+              <a:rPr sz="1100">
                 <a:solidFill>
                   <a:srgbClr val="333333"/>
                 </a:solidFill>
-                <a:latin typeface="Calibri"/>
-              </a:defRPr>
-            </a:pPr>
-            <a:r>
-              <a:t>의도 기반 라우팅</a:t>
+              </a:rPr>
+              <a:t>Ollama LLM Intent Classification (temperature=0.0)
+→ Paper / Search / Report 라우팅
+Agent Trace 실시간 시각화</a:t>
             </a:r>
           </a:p>
         </p:txBody>
@@ -8700,23 +8673,14 @@
               </a:defRPr>
             </a:pPr>
             <a:r>
-              <a:t>최신 논문 검색</a:t>
-            </a:r>
-          </a:p>
-          <a:p>
-            <a:pPr algn="ctr">
-              <a:spcAft>
-                <a:spcPts val="400"/>
-              </a:spcAft>
-              <a:defRPr sz="1300" b="0">
+              <a:rPr sz="1100">
                 <a:solidFill>
                   <a:srgbClr val="333333"/>
                 </a:solidFill>
-                <a:latin typeface="Calibri"/>
-              </a:defRPr>
-            </a:pPr>
-            <a:r>
-              <a:t>+ LLM 요약 생성</a:t>
+              </a:rPr>
+              <a:t>Arxiv 4.x API + 1h In-Memory Cache
++ Query Optimizer Agent
++ LLM Batch Summarization</a:t>
             </a:r>
           </a:p>
         </p:txBody>
@@ -8836,23 +8800,13 @@
               </a:defRPr>
             </a:pPr>
             <a:r>
-              <a:t>RAG + Search 통합 보고서</a:t>
-            </a:r>
-          </a:p>
-          <a:p>
-            <a:pPr algn="ctr">
-              <a:spcAft>
-                <a:spcPts val="400"/>
-              </a:spcAft>
-              <a:defRPr sz="1300" b="0">
+              <a:rPr sz="1100">
                 <a:solidFill>
                   <a:srgbClr val="333333"/>
                 </a:solidFill>
-                <a:latin typeface="Calibri"/>
-              </a:defRPr>
-            </a:pPr>
-            <a:r>
-              <a:t>Markdown 자동 포맷팅</a:t>
+              </a:rPr>
+              <a:t>RAG + Search 통합 보고서
+Markdown 자동 포맷팅, 출처 인용 포함</a:t>
             </a:r>
           </a:p>
         </p:txBody>
@@ -8972,23 +8926,14 @@
               </a:defRPr>
             </a:pPr>
             <a:r>
-              <a:t>실시간 Agent 의사결정</a:t>
-            </a:r>
-          </a:p>
-          <a:p>
-            <a:pPr algn="ctr">
-              <a:spcAft>
-                <a:spcPts val="400"/>
-              </a:spcAft>
-              <a:defRPr sz="1300" b="0">
+              <a:rPr sz="1100">
                 <a:solidFill>
                   <a:srgbClr val="333333"/>
                 </a:solidFill>
-                <a:latin typeface="Calibri"/>
-              </a:defRPr>
-            </a:pPr>
-            <a:r>
-              <a:t>과정 시각화</a:t>
+              </a:rPr>
+              <a:t>Supervisor → Agent 선택 → 실행 → 완료
+4단계 Trace 실시간 표시
+각 Agent 상태/결과 표시</a:t>
             </a:r>
           </a:p>
         </p:txBody>
@@ -9213,7 +9158,16 @@
               </a:defRPr>
             </a:pPr>
             <a:r>
-              <a:t>Ollama qwen3.5:4b, temperature=0.0, num_predict=64</a:t>
+              <a:rPr sz="1100" b="0">
+                <a:solidFill>
+                  <a:srgbClr val="333333"/>
+                </a:solidFill>
+              </a:rPr>
+              <a:t>Ollama qwen3.5:4b, temperature=0.0, num_predict=64
+Intent → paper: RAG 질의 | search: Arxiv 검색 | report: 통합 보고서
+● v1: Keyword-based classification (rule-based, fragile)
+● v2 (current): LLM classification with few-shot examples → deterministic label
+  route() 메서드가 supervise() 결과받아 Agent 라우팅</a:t>
             </a:r>
           </a:p>
           <a:p>
@@ -9365,7 +9319,19 @@
               </a:defRPr>
             </a:pPr>
             <a:r>
-              <a:t>• RAGChain wrapping FAISS + Ollama</a:t>
+              <a:rPr sz="1100" b="0">
+                <a:solidFill>
+                  <a:srgbClr val="333333"/>
+                </a:solidFill>
+              </a:rPr>
+              <a:t>• RAGChain wrapping FAISS + BGE-m3 + Ollama
+• RetrievalQA (chain_type='stuff') + Source Citation
+• Phase 0: Semantic Chunking (section-aware boundary)
+• Phase 1: Query Rewriting (HyDE + Decomposition + Expansion)
+• Phase 2: Multi-Strategy Retrieval (Multi-Query + RRF Fusion)
+• Phase 3: Academic Prompt Engineering (5 prompt templates)
+• Phase 4: Answer Verification (claim grounding check)
+• Phase 5: Analyst Pipeline (multi-step analysis workflow)</a:t>
             </a:r>
           </a:p>
           <a:p>
@@ -9549,7 +9515,17 @@
               </a:defRPr>
             </a:pPr>
             <a:r>
-              <a:t>• Arxiv API (no API key needed)</a:t>
+              <a:rPr sz="1100" b="0">
+                <a:solidFill>
+                  <a:srgbClr val="333333"/>
+                </a:solidFill>
+              </a:rPr>
+              <a:t>• Arxiv API (no API key needed, 4.x Client API)
+• 1-hour in-memory cache
+• LLM-generated paper summaries + batch summarize
+• Detail fetch by Arxiv ID + get_short_id()
+• Query Optimizer Agent: rewrite → expand → search
+• Max results configurable</a:t>
             </a:r>
           </a:p>
           <a:p>
@@ -12672,6 +12648,771 @@
           </a:p>
         </p:txBody>
       </p:sp>
+      <p:sp>
+        <p:nvSpPr>
+          <p:cNvPr id="74" name="TextBox 73"/>
+          <p:cNvSpPr txBox="1"/>
+          <p:nvPr/>
+        </p:nvSpPr>
+        <p:spPr>
+          <a:xfrm>
+            <a:off x="731520" y="4339080"/>
+            <a:ext cx="457200" cy="274320"/>
+          </a:xfrm>
+          <a:prstGeom prst="rect">
+            <a:avLst/>
+          </a:prstGeom>
+          <a:noFill/>
+        </p:spPr>
+        <p:txBody>
+          <a:bodyPr wrap="square">
+            <a:spAutoFit/>
+          </a:bodyPr>
+          <a:lstStyle/>
+          <a:p>
+            <a:pPr algn="l">
+              <a:spcAft>
+                <a:spcPts val="200"/>
+              </a:spcAft>
+            </a:pPr>
+            <a:r>
+              <a:rPr sz="1000" b="1">
+                <a:solidFill>
+                  <a:srgbClr val="1A1A2E"/>
+                </a:solidFill>
+              </a:rPr>
+              <a:t>Q7</a:t>
+            </a:r>
+          </a:p>
+        </p:txBody>
+      </p:sp>
+      <p:sp>
+        <p:nvSpPr>
+          <p:cNvPr id="75" name="TextBox 74"/>
+          <p:cNvSpPr txBox="1"/>
+          <p:nvPr/>
+        </p:nvSpPr>
+        <p:spPr>
+          <a:xfrm>
+            <a:off x="1280160" y="4339080"/>
+            <a:ext cx="1097280" cy="274320"/>
+          </a:xfrm>
+          <a:prstGeom prst="rect">
+            <a:avLst/>
+          </a:prstGeom>
+          <a:noFill/>
+        </p:spPr>
+        <p:txBody>
+          <a:bodyPr wrap="square">
+            <a:spAutoFit/>
+          </a:bodyPr>
+          <a:lstStyle/>
+          <a:p>
+            <a:pPr algn="l">
+              <a:spcAft>
+                <a:spcPts val="200"/>
+              </a:spcAft>
+            </a:pPr>
+            <a:r>
+              <a:rPr sz="1000" b="0">
+                <a:solidFill>
+                  <a:srgbClr val="333333"/>
+                </a:solidFill>
+              </a:rPr>
+              <a:t>PDF Parser</a:t>
+            </a:r>
+          </a:p>
+        </p:txBody>
+      </p:sp>
+      <p:sp>
+        <p:nvSpPr>
+          <p:cNvPr id="76" name="TextBox 75"/>
+          <p:cNvSpPr txBox="1"/>
+          <p:nvPr/>
+        </p:nvSpPr>
+        <p:spPr>
+          <a:xfrm>
+            <a:off x="2743200" y="4339080"/>
+            <a:ext cx="1828800" cy="274320"/>
+          </a:xfrm>
+          <a:prstGeom prst="rect">
+            <a:avLst/>
+          </a:prstGeom>
+          <a:noFill/>
+        </p:spPr>
+        <p:txBody>
+          <a:bodyPr wrap="square">
+            <a:spAutoFit/>
+          </a:bodyPr>
+          <a:lstStyle/>
+          <a:p>
+            <a:pPr algn="l">
+              <a:spcAft>
+                <a:spcPts val="200"/>
+              </a:spcAft>
+            </a:pPr>
+            <a:r>
+              <a:rPr sz="1000" b="0">
+                <a:solidFill>
+                  <a:srgbClr val="333333"/>
+                </a:solidFill>
+              </a:rPr>
+              <a:t>PyMuPDF vs PyMuPDF4LLM</a:t>
+            </a:r>
+          </a:p>
+        </p:txBody>
+      </p:sp>
+      <p:sp>
+        <p:nvSpPr>
+          <p:cNvPr id="77" name="TextBox 76"/>
+          <p:cNvSpPr txBox="1"/>
+          <p:nvPr/>
+        </p:nvSpPr>
+        <p:spPr>
+          <a:xfrm>
+            <a:off x="4937760" y="4339080"/>
+            <a:ext cx="914400" cy="274320"/>
+          </a:xfrm>
+          <a:prstGeom prst="rect">
+            <a:avLst/>
+          </a:prstGeom>
+          <a:noFill/>
+        </p:spPr>
+        <p:txBody>
+          <a:bodyPr wrap="square">
+            <a:spAutoFit/>
+          </a:bodyPr>
+          <a:lstStyle/>
+          <a:p>
+            <a:pPr algn="l">
+              <a:spcAft>
+                <a:spcPts val="200"/>
+              </a:spcAft>
+            </a:pPr>
+            <a:r>
+              <a:rPr sz="1000" b="1">
+                <a:solidFill>
+                  <a:srgbClr val="0070C0"/>
+                </a:solidFill>
+              </a:rPr>
+              <a:t>PyMuPDF4LLM</a:t>
+            </a:r>
+          </a:p>
+        </p:txBody>
+      </p:sp>
+      <p:sp>
+        <p:nvSpPr>
+          <p:cNvPr id="78" name="TextBox 77"/>
+          <p:cNvSpPr txBox="1"/>
+          <p:nvPr/>
+        </p:nvSpPr>
+        <p:spPr>
+          <a:xfrm>
+            <a:off x="6217920" y="4339080"/>
+            <a:ext cx="2743200" cy="457200"/>
+          </a:xfrm>
+          <a:prstGeom prst="rect">
+            <a:avLst/>
+          </a:prstGeom>
+          <a:noFill/>
+        </p:spPr>
+        <p:txBody>
+          <a:bodyPr wrap="square">
+            <a:spAutoFit/>
+          </a:bodyPr>
+          <a:lstStyle/>
+          <a:p>
+            <a:pPr algn="l">
+              <a:spcAft>
+                <a:spcPts val="200"/>
+              </a:spcAft>
+            </a:pPr>
+            <a:r>
+              <a:rPr sz="1000" b="0">
+                <a:solidFill>
+                  <a:srgbClr val="333333"/>
+                </a:solidFill>
+              </a:rPr>
+              <a:t>Layout-aware 추출, 다단 읽기,
+OCR fallback, 학습된 parser</a:t>
+            </a:r>
+          </a:p>
+        </p:txBody>
+      </p:sp>
+      <p:sp>
+        <p:nvSpPr>
+          <p:cNvPr id="79" name="TextBox 78"/>
+          <p:cNvSpPr txBox="1"/>
+          <p:nvPr/>
+        </p:nvSpPr>
+        <p:spPr>
+          <a:xfrm>
+            <a:off x="731520" y="4746240"/>
+            <a:ext cx="457200" cy="274320"/>
+          </a:xfrm>
+          <a:prstGeom prst="rect">
+            <a:avLst/>
+          </a:prstGeom>
+          <a:noFill/>
+        </p:spPr>
+        <p:txBody>
+          <a:bodyPr wrap="square">
+            <a:spAutoFit/>
+          </a:bodyPr>
+          <a:lstStyle/>
+          <a:p>
+            <a:pPr algn="l">
+              <a:spcAft>
+                <a:spcPts val="200"/>
+              </a:spcAft>
+            </a:pPr>
+            <a:r>
+              <a:rPr sz="1000" b="1">
+                <a:solidFill>
+                  <a:srgbClr val="1A1A2E"/>
+                </a:solidFill>
+              </a:rPr>
+              <a:t>Q8</a:t>
+            </a:r>
+          </a:p>
+        </p:txBody>
+      </p:sp>
+      <p:sp>
+        <p:nvSpPr>
+          <p:cNvPr id="80" name="TextBox 79"/>
+          <p:cNvSpPr txBox="1"/>
+          <p:nvPr/>
+        </p:nvSpPr>
+        <p:spPr>
+          <a:xfrm>
+            <a:off x="1280160" y="4746240"/>
+            <a:ext cx="1097280" cy="274320"/>
+          </a:xfrm>
+          <a:prstGeom prst="rect">
+            <a:avLst/>
+          </a:prstGeom>
+          <a:noFill/>
+        </p:spPr>
+        <p:txBody>
+          <a:bodyPr wrap="square">
+            <a:spAutoFit/>
+          </a:bodyPr>
+          <a:lstStyle/>
+          <a:p>
+            <a:pPr algn="l">
+              <a:spcAft>
+                <a:spcPts val="200"/>
+              </a:spcAft>
+            </a:pPr>
+            <a:r>
+              <a:rPr sz="1000" b="0">
+                <a:solidFill>
+                  <a:srgbClr val="333333"/>
+                </a:solidFill>
+              </a:rPr>
+              <a:t>Intent Class.</a:t>
+            </a:r>
+          </a:p>
+        </p:txBody>
+      </p:sp>
+      <p:sp>
+        <p:nvSpPr>
+          <p:cNvPr id="81" name="TextBox 80"/>
+          <p:cNvSpPr txBox="1"/>
+          <p:nvPr/>
+        </p:nvSpPr>
+        <p:spPr>
+          <a:xfrm>
+            <a:off x="2743200" y="4746240"/>
+            <a:ext cx="1828800" cy="274320"/>
+          </a:xfrm>
+          <a:prstGeom prst="rect">
+            <a:avLst/>
+          </a:prstGeom>
+          <a:noFill/>
+        </p:spPr>
+        <p:txBody>
+          <a:bodyPr wrap="square">
+            <a:spAutoFit/>
+          </a:bodyPr>
+          <a:lstStyle/>
+          <a:p>
+            <a:pPr algn="l">
+              <a:spcAft>
+                <a:spcPts val="200"/>
+              </a:spcAft>
+            </a:pPr>
+            <a:r>
+              <a:rPr sz="1000" b="0">
+                <a:solidFill>
+                  <a:srgbClr val="333333"/>
+                </a:solidFill>
+              </a:rPr>
+              <a:t>Keyword vs LLM</a:t>
+            </a:r>
+          </a:p>
+        </p:txBody>
+      </p:sp>
+      <p:sp>
+        <p:nvSpPr>
+          <p:cNvPr id="82" name="TextBox 81"/>
+          <p:cNvSpPr txBox="1"/>
+          <p:nvPr/>
+        </p:nvSpPr>
+        <p:spPr>
+          <a:xfrm>
+            <a:off x="4937760" y="4746240"/>
+            <a:ext cx="914400" cy="274320"/>
+          </a:xfrm>
+          <a:prstGeom prst="rect">
+            <a:avLst/>
+          </a:prstGeom>
+          <a:noFill/>
+        </p:spPr>
+        <p:txBody>
+          <a:bodyPr wrap="square">
+            <a:spAutoFit/>
+          </a:bodyPr>
+          <a:lstStyle/>
+          <a:p>
+            <a:pPr algn="l">
+              <a:spcAft>
+                <a:spcPts val="200"/>
+              </a:spcAft>
+            </a:pPr>
+            <a:r>
+              <a:rPr sz="1000" b="1">
+                <a:solidFill>
+                  <a:srgbClr val="0070C0"/>
+                </a:solidFill>
+              </a:rPr>
+              <a:t>LLM (Ollama)</a:t>
+            </a:r>
+          </a:p>
+        </p:txBody>
+      </p:sp>
+      <p:sp>
+        <p:nvSpPr>
+          <p:cNvPr id="83" name="TextBox 82"/>
+          <p:cNvSpPr txBox="1"/>
+          <p:nvPr/>
+        </p:nvSpPr>
+        <p:spPr>
+          <a:xfrm>
+            <a:off x="6217920" y="4746240"/>
+            <a:ext cx="2743200" cy="457200"/>
+          </a:xfrm>
+          <a:prstGeom prst="rect">
+            <a:avLst/>
+          </a:prstGeom>
+          <a:noFill/>
+        </p:spPr>
+        <p:txBody>
+          <a:bodyPr wrap="square">
+            <a:spAutoFit/>
+          </a:bodyPr>
+          <a:lstStyle/>
+          <a:p>
+            <a:pPr algn="l">
+              <a:spcAft>
+                <a:spcPts val="200"/>
+              </a:spcAft>
+            </a:pPr>
+            <a:r>
+              <a:rPr sz="1000" b="0">
+                <a:solidFill>
+                  <a:srgbClr val="333333"/>
+                </a:solidFill>
+              </a:rPr>
+              <a:t>확장성, 평가 반영,
+few-shot으로 안정화</a:t>
+            </a:r>
+          </a:p>
+        </p:txBody>
+      </p:sp>
+      <p:sp>
+        <p:nvSpPr>
+          <p:cNvPr id="84" name="TextBox 83"/>
+          <p:cNvSpPr txBox="1"/>
+          <p:nvPr/>
+        </p:nvSpPr>
+        <p:spPr>
+          <a:xfrm>
+            <a:off x="731520" y="5153400"/>
+            <a:ext cx="457200" cy="274320"/>
+          </a:xfrm>
+          <a:prstGeom prst="rect">
+            <a:avLst/>
+          </a:prstGeom>
+          <a:noFill/>
+        </p:spPr>
+        <p:txBody>
+          <a:bodyPr wrap="square">
+            <a:spAutoFit/>
+          </a:bodyPr>
+          <a:lstStyle/>
+          <a:p>
+            <a:pPr algn="l">
+              <a:spcAft>
+                <a:spcPts val="200"/>
+              </a:spcAft>
+            </a:pPr>
+            <a:r>
+              <a:rPr sz="1000" b="1">
+                <a:solidFill>
+                  <a:srgbClr val="1A1A2E"/>
+                </a:solidFill>
+              </a:rPr>
+              <a:t>Q9</a:t>
+            </a:r>
+          </a:p>
+        </p:txBody>
+      </p:sp>
+      <p:sp>
+        <p:nvSpPr>
+          <p:cNvPr id="85" name="TextBox 84"/>
+          <p:cNvSpPr txBox="1"/>
+          <p:nvPr/>
+        </p:nvSpPr>
+        <p:spPr>
+          <a:xfrm>
+            <a:off x="1280160" y="5153400"/>
+            <a:ext cx="1097280" cy="274320"/>
+          </a:xfrm>
+          <a:prstGeom prst="rect">
+            <a:avLst/>
+          </a:prstGeom>
+          <a:noFill/>
+        </p:spPr>
+        <p:txBody>
+          <a:bodyPr wrap="square">
+            <a:spAutoFit/>
+          </a:bodyPr>
+          <a:lstStyle/>
+          <a:p>
+            <a:pPr algn="l">
+              <a:spcAft>
+                <a:spcPts val="200"/>
+              </a:spcAft>
+            </a:pPr>
+            <a:r>
+              <a:rPr sz="1000" b="0">
+                <a:solidFill>
+                  <a:srgbClr val="333333"/>
+                </a:solidFill>
+              </a:rPr>
+              <a:t>Batch Ingest</a:t>
+            </a:r>
+          </a:p>
+        </p:txBody>
+      </p:sp>
+      <p:sp>
+        <p:nvSpPr>
+          <p:cNvPr id="86" name="TextBox 85"/>
+          <p:cNvSpPr txBox="1"/>
+          <p:nvPr/>
+        </p:nvSpPr>
+        <p:spPr>
+          <a:xfrm>
+            <a:off x="2743200" y="5153400"/>
+            <a:ext cx="1828800" cy="274320"/>
+          </a:xfrm>
+          <a:prstGeom prst="rect">
+            <a:avLst/>
+          </a:prstGeom>
+          <a:noFill/>
+        </p:spPr>
+        <p:txBody>
+          <a:bodyPr wrap="square">
+            <a:spAutoFit/>
+          </a:bodyPr>
+          <a:lstStyle/>
+          <a:p>
+            <a:pPr algn="l">
+              <a:spcAft>
+                <a:spcPts val="200"/>
+              </a:spcAft>
+            </a:pPr>
+            <a:r>
+              <a:rPr sz="1000" b="0">
+                <a:solidFill>
+                  <a:srgbClr val="333333"/>
+                </a:solidFill>
+              </a:rPr>
+              <a:t>Single vs Multi</a:t>
+            </a:r>
+          </a:p>
+        </p:txBody>
+      </p:sp>
+      <p:sp>
+        <p:nvSpPr>
+          <p:cNvPr id="87" name="TextBox 86"/>
+          <p:cNvSpPr txBox="1"/>
+          <p:nvPr/>
+        </p:nvSpPr>
+        <p:spPr>
+          <a:xfrm>
+            <a:off x="4937760" y="5153400"/>
+            <a:ext cx="914400" cy="274320"/>
+          </a:xfrm>
+          <a:prstGeom prst="rect">
+            <a:avLst/>
+          </a:prstGeom>
+          <a:noFill/>
+        </p:spPr>
+        <p:txBody>
+          <a:bodyPr wrap="square">
+            <a:spAutoFit/>
+          </a:bodyPr>
+          <a:lstStyle/>
+          <a:p>
+            <a:pPr algn="l">
+              <a:spcAft>
+                <a:spcPts val="200"/>
+              </a:spcAft>
+            </a:pPr>
+            <a:r>
+              <a:rPr sz="1000" b="1">
+                <a:solidFill>
+                  <a:srgbClr val="0070C0"/>
+                </a:solidFill>
+              </a:rPr>
+              <a:t>Multi (Batch)</a:t>
+            </a:r>
+          </a:p>
+        </p:txBody>
+      </p:sp>
+      <p:sp>
+        <p:nvSpPr>
+          <p:cNvPr id="88" name="TextBox 87"/>
+          <p:cNvSpPr txBox="1"/>
+          <p:nvPr/>
+        </p:nvSpPr>
+        <p:spPr>
+          <a:xfrm>
+            <a:off x="6217920" y="5153400"/>
+            <a:ext cx="2743200" cy="457200"/>
+          </a:xfrm>
+          <a:prstGeom prst="rect">
+            <a:avLst/>
+          </a:prstGeom>
+          <a:noFill/>
+        </p:spPr>
+        <p:txBody>
+          <a:bodyPr wrap="square">
+            <a:spAutoFit/>
+          </a:bodyPr>
+          <a:lstStyle/>
+          <a:p>
+            <a:pPr algn="l">
+              <a:spcAft>
+                <a:spcPts val="200"/>
+              </a:spcAft>
+            </a:pPr>
+            <a:r>
+              <a:rPr sz="1000" b="0">
+                <a:solidFill>
+                  <a:srgbClr val="333333"/>
+                </a:solidFill>
+              </a:rPr>
+              <a:t>사용자 편의성,
+vector store merge</a:t>
+            </a:r>
+          </a:p>
+        </p:txBody>
+      </p:sp>
+      <p:sp>
+        <p:nvSpPr>
+          <p:cNvPr id="89" name="TextBox 88"/>
+          <p:cNvSpPr txBox="1"/>
+          <p:nvPr/>
+        </p:nvSpPr>
+        <p:spPr>
+          <a:xfrm>
+            <a:off x="731520" y="5560560"/>
+            <a:ext cx="457200" cy="274320"/>
+          </a:xfrm>
+          <a:prstGeom prst="rect">
+            <a:avLst/>
+          </a:prstGeom>
+          <a:noFill/>
+        </p:spPr>
+        <p:txBody>
+          <a:bodyPr wrap="square">
+            <a:spAutoFit/>
+          </a:bodyPr>
+          <a:lstStyle/>
+          <a:p>
+            <a:pPr algn="l">
+              <a:spcAft>
+                <a:spcPts val="200"/>
+              </a:spcAft>
+            </a:pPr>
+            <a:r>
+              <a:rPr sz="1000" b="1">
+                <a:solidFill>
+                  <a:srgbClr val="1A1A2E"/>
+                </a:solidFill>
+              </a:rPr>
+              <a:t>Q10</a:t>
+            </a:r>
+          </a:p>
+        </p:txBody>
+      </p:sp>
+      <p:sp>
+        <p:nvSpPr>
+          <p:cNvPr id="90" name="TextBox 89"/>
+          <p:cNvSpPr txBox="1"/>
+          <p:nvPr/>
+        </p:nvSpPr>
+        <p:spPr>
+          <a:xfrm>
+            <a:off x="1280160" y="5560560"/>
+            <a:ext cx="1097280" cy="274320"/>
+          </a:xfrm>
+          <a:prstGeom prst="rect">
+            <a:avLst/>
+          </a:prstGeom>
+          <a:noFill/>
+        </p:spPr>
+        <p:txBody>
+          <a:bodyPr wrap="square">
+            <a:spAutoFit/>
+          </a:bodyPr>
+          <a:lstStyle/>
+          <a:p>
+            <a:pPr algn="l">
+              <a:spcAft>
+                <a:spcPts val="200"/>
+              </a:spcAft>
+            </a:pPr>
+            <a:r>
+              <a:rPr sz="1000" b="0">
+                <a:solidFill>
+                  <a:srgbClr val="333333"/>
+                </a:solidFill>
+              </a:rPr>
+              <a:t>Vector Reset</a:t>
+            </a:r>
+          </a:p>
+        </p:txBody>
+      </p:sp>
+      <p:sp>
+        <p:nvSpPr>
+          <p:cNvPr id="91" name="TextBox 90"/>
+          <p:cNvSpPr txBox="1"/>
+          <p:nvPr/>
+        </p:nvSpPr>
+        <p:spPr>
+          <a:xfrm>
+            <a:off x="2743200" y="5560560"/>
+            <a:ext cx="1828800" cy="274320"/>
+          </a:xfrm>
+          <a:prstGeom prst="rect">
+            <a:avLst/>
+          </a:prstGeom>
+          <a:noFill/>
+        </p:spPr>
+        <p:txBody>
+          <a:bodyPr wrap="square">
+            <a:spAutoFit/>
+          </a:bodyPr>
+          <a:lstStyle/>
+          <a:p>
+            <a:pPr algn="l">
+              <a:spcAft>
+                <a:spcPts val="200"/>
+              </a:spcAft>
+            </a:pPr>
+            <a:r>
+              <a:rPr sz="1000" b="0">
+                <a:solidFill>
+                  <a:srgbClr val="333333"/>
+                </a:solidFill>
+              </a:rPr>
+              <a:t>UI Button
++ 2-step confirm</a:t>
+            </a:r>
+          </a:p>
+        </p:txBody>
+      </p:sp>
+      <p:sp>
+        <p:nvSpPr>
+          <p:cNvPr id="92" name="TextBox 91"/>
+          <p:cNvSpPr txBox="1"/>
+          <p:nvPr/>
+        </p:nvSpPr>
+        <p:spPr>
+          <a:xfrm>
+            <a:off x="4937760" y="5560560"/>
+            <a:ext cx="914400" cy="274320"/>
+          </a:xfrm>
+          <a:prstGeom prst="rect">
+            <a:avLst/>
+          </a:prstGeom>
+          <a:noFill/>
+        </p:spPr>
+        <p:txBody>
+          <a:bodyPr wrap="square">
+            <a:spAutoFit/>
+          </a:bodyPr>
+          <a:lstStyle/>
+          <a:p>
+            <a:pPr algn="l">
+              <a:spcAft>
+                <a:spcPts val="200"/>
+              </a:spcAft>
+            </a:pPr>
+            <a:r>
+              <a:rPr sz="1000" b="1">
+                <a:solidFill>
+                  <a:srgbClr val="0070C0"/>
+                </a:solidFill>
+              </a:rPr>
+              <a:t>2-step Confirm</a:t>
+            </a:r>
+          </a:p>
+        </p:txBody>
+      </p:sp>
+      <p:sp>
+        <p:nvSpPr>
+          <p:cNvPr id="93" name="TextBox 92"/>
+          <p:cNvSpPr txBox="1"/>
+          <p:nvPr/>
+        </p:nvSpPr>
+        <p:spPr>
+          <a:xfrm>
+            <a:off x="6217920" y="5560560"/>
+            <a:ext cx="2743200" cy="457200"/>
+          </a:xfrm>
+          <a:prstGeom prst="rect">
+            <a:avLst/>
+          </a:prstGeom>
+          <a:noFill/>
+        </p:spPr>
+        <p:txBody>
+          <a:bodyPr wrap="square">
+            <a:spAutoFit/>
+          </a:bodyPr>
+          <a:lstStyle/>
+          <a:p>
+            <a:pPr algn="l">
+              <a:spcAft>
+                <a:spcPts val="200"/>
+              </a:spcAft>
+            </a:pPr>
+            <a:r>
+              <a:rPr sz="1000" b="0">
+                <a:solidFill>
+                  <a:srgbClr val="333333"/>
+                </a:solidFill>
+              </a:rPr>
+              <a:t>실수 방지,
+사용자 명시적 동의</a:t>
+            </a:r>
+          </a:p>
+        </p:txBody>
+      </p:sp>
     </p:spTree>
   </p:cSld>
   <p:clrMapOvr>
@@ -15653,6 +16394,1230 @@
             </a:pPr>
             <a:r>
               <a:t>Import 체인 검증 완료</a:t>
+            </a:r>
+          </a:p>
+        </p:txBody>
+      </p:sp>
+      <p:sp>
+        <p:nvSpPr>
+          <p:cNvPr id="77" name="TextBox 76"/>
+          <p:cNvSpPr txBox="1"/>
+          <p:nvPr/>
+        </p:nvSpPr>
+        <p:spPr>
+          <a:xfrm>
+            <a:off x="777240" y="5715000"/>
+            <a:ext cx="365760" cy="274320"/>
+          </a:xfrm>
+          <a:prstGeom prst="rect">
+            <a:avLst/>
+          </a:prstGeom>
+          <a:noFill/>
+        </p:spPr>
+        <p:txBody>
+          <a:bodyPr wrap="square">
+            <a:spAutoFit/>
+          </a:bodyPr>
+          <a:lstStyle/>
+          <a:p>
+            <a:pPr algn="l">
+              <a:spcAft>
+                <a:spcPts val="200"/>
+              </a:spcAft>
+            </a:pPr>
+            <a:r>
+              <a:rPr sz="1000" b="1">
+                <a:solidFill>
+                  <a:srgbClr val="1A1A2E"/>
+                </a:solidFill>
+              </a:rPr>
+              <a:t>09</a:t>
+            </a:r>
+          </a:p>
+        </p:txBody>
+      </p:sp>
+      <p:sp>
+        <p:nvSpPr>
+          <p:cNvPr id="78" name="TextBox 77"/>
+          <p:cNvSpPr txBox="1"/>
+          <p:nvPr/>
+        </p:nvSpPr>
+        <p:spPr>
+          <a:xfrm>
+            <a:off x="1234440" y="5715000"/>
+            <a:ext cx="2743200" cy="274320"/>
+          </a:xfrm>
+          <a:prstGeom prst="rect">
+            <a:avLst/>
+          </a:prstGeom>
+          <a:noFill/>
+        </p:spPr>
+        <p:txBody>
+          <a:bodyPr wrap="square">
+            <a:spAutoFit/>
+          </a:bodyPr>
+          <a:lstStyle/>
+          <a:p>
+            <a:pPr algn="l">
+              <a:spcAft>
+                <a:spcPts val="200"/>
+              </a:spcAft>
+            </a:pPr>
+            <a:r>
+              <a:rPr sz="1000" b="0">
+                <a:solidFill>
+                  <a:srgbClr val="333333"/>
+                </a:solidFill>
+              </a:rPr>
+              <a:t>arxiv 4.x API 호환</a:t>
+            </a:r>
+          </a:p>
+        </p:txBody>
+      </p:sp>
+      <p:sp>
+        <p:nvSpPr>
+          <p:cNvPr id="79" name="TextBox 78"/>
+          <p:cNvSpPr txBox="1"/>
+          <p:nvPr/>
+        </p:nvSpPr>
+        <p:spPr>
+          <a:xfrm>
+            <a:off x="3794760" y="5715000"/>
+            <a:ext cx="640080" cy="274320"/>
+          </a:xfrm>
+          <a:prstGeom prst="rect">
+            <a:avLst/>
+          </a:prstGeom>
+          <a:noFill/>
+        </p:spPr>
+        <p:txBody>
+          <a:bodyPr wrap="square">
+            <a:spAutoFit/>
+          </a:bodyPr>
+          <a:lstStyle/>
+          <a:p>
+            <a:pPr algn="l">
+              <a:spcAft>
+                <a:spcPts val="200"/>
+              </a:spcAft>
+            </a:pPr>
+            <a:r>
+              <a:rPr sz="1000" b="1">
+                <a:solidFill>
+                  <a:srgbClr val="D05050"/>
+                </a:solidFill>
+              </a:rPr>
+              <a:t>code</a:t>
+            </a:r>
+          </a:p>
+        </p:txBody>
+      </p:sp>
+      <p:sp>
+        <p:nvSpPr>
+          <p:cNvPr id="80" name="TextBox 79"/>
+          <p:cNvSpPr txBox="1"/>
+          <p:nvPr/>
+        </p:nvSpPr>
+        <p:spPr>
+          <a:xfrm>
+            <a:off x="4526280" y="5715000"/>
+            <a:ext cx="3657600" cy="457200"/>
+          </a:xfrm>
+          <a:prstGeom prst="rect">
+            <a:avLst/>
+          </a:prstGeom>
+          <a:noFill/>
+        </p:spPr>
+        <p:txBody>
+          <a:bodyPr wrap="square">
+            <a:spAutoFit/>
+          </a:bodyPr>
+          <a:lstStyle/>
+          <a:p>
+            <a:pPr algn="l">
+              <a:spcAft>
+                <a:spcPts val="200"/>
+              </a:spcAft>
+            </a:pPr>
+            <a:r>
+              <a:rPr sz="1000" b="0">
+                <a:solidFill>
+                  <a:srgbClr val="333333"/>
+                </a:solidFill>
+              </a:rPr>
+              <a:t>버전 고정 부재 → Client API로 마이그레이션,
+requirements.txt 버전 제한</a:t>
+            </a:r>
+          </a:p>
+        </p:txBody>
+      </p:sp>
+      <p:sp>
+        <p:nvSpPr>
+          <p:cNvPr id="81" name="TextBox 80"/>
+          <p:cNvSpPr txBox="1"/>
+          <p:nvPr/>
+        </p:nvSpPr>
+        <p:spPr>
+          <a:xfrm>
+            <a:off x="777240" y="6172200"/>
+            <a:ext cx="365760" cy="274320"/>
+          </a:xfrm>
+          <a:prstGeom prst="rect">
+            <a:avLst/>
+          </a:prstGeom>
+          <a:noFill/>
+        </p:spPr>
+        <p:txBody>
+          <a:bodyPr wrap="square">
+            <a:spAutoFit/>
+          </a:bodyPr>
+          <a:lstStyle/>
+          <a:p>
+            <a:pPr algn="l">
+              <a:spcAft>
+                <a:spcPts val="200"/>
+              </a:spcAft>
+            </a:pPr>
+            <a:r>
+              <a:rPr sz="1000" b="1">
+                <a:solidFill>
+                  <a:srgbClr val="1A1A2E"/>
+                </a:solidFill>
+              </a:rPr>
+              <a:t>10</a:t>
+            </a:r>
+          </a:p>
+        </p:txBody>
+      </p:sp>
+      <p:sp>
+        <p:nvSpPr>
+          <p:cNvPr id="82" name="TextBox 81"/>
+          <p:cNvSpPr txBox="1"/>
+          <p:nvPr/>
+        </p:nvSpPr>
+        <p:spPr>
+          <a:xfrm>
+            <a:off x="1234440" y="6172200"/>
+            <a:ext cx="2743200" cy="274320"/>
+          </a:xfrm>
+          <a:prstGeom prst="rect">
+            <a:avLst/>
+          </a:prstGeom>
+          <a:noFill/>
+        </p:spPr>
+        <p:txBody>
+          <a:bodyPr wrap="square">
+            <a:spAutoFit/>
+          </a:bodyPr>
+          <a:lstStyle/>
+          <a:p>
+            <a:pPr algn="l">
+              <a:spcAft>
+                <a:spcPts val="200"/>
+              </a:spcAft>
+            </a:pPr>
+            <a:r>
+              <a:rPr sz="1000" b="0">
+                <a:solidFill>
+                  <a:srgbClr val="333333"/>
+                </a:solidFill>
+              </a:rPr>
+              <a:t>Ingest 성능 진단</a:t>
+            </a:r>
+          </a:p>
+        </p:txBody>
+      </p:sp>
+      <p:sp>
+        <p:nvSpPr>
+          <p:cNvPr id="83" name="TextBox 82"/>
+          <p:cNvSpPr txBox="1"/>
+          <p:nvPr/>
+        </p:nvSpPr>
+        <p:spPr>
+          <a:xfrm>
+            <a:off x="3794760" y="6172200"/>
+            <a:ext cx="640080" cy="274320"/>
+          </a:xfrm>
+          <a:prstGeom prst="rect">
+            <a:avLst/>
+          </a:prstGeom>
+          <a:noFill/>
+        </p:spPr>
+        <p:txBody>
+          <a:bodyPr wrap="square">
+            <a:spAutoFit/>
+          </a:bodyPr>
+          <a:lstStyle/>
+          <a:p>
+            <a:pPr algn="l">
+              <a:spcAft>
+                <a:spcPts val="200"/>
+              </a:spcAft>
+            </a:pPr>
+            <a:r>
+              <a:rPr sz="1000" b="1">
+                <a:solidFill>
+                  <a:srgbClr val="0070C0"/>
+                </a:solidFill>
+              </a:rPr>
+              <a:t>decision</a:t>
+            </a:r>
+          </a:p>
+        </p:txBody>
+      </p:sp>
+      <p:sp>
+        <p:nvSpPr>
+          <p:cNvPr id="84" name="TextBox 83"/>
+          <p:cNvSpPr txBox="1"/>
+          <p:nvPr/>
+        </p:nvSpPr>
+        <p:spPr>
+          <a:xfrm>
+            <a:off x="4526280" y="6172200"/>
+            <a:ext cx="3657600" cy="457200"/>
+          </a:xfrm>
+          <a:prstGeom prst="rect">
+            <a:avLst/>
+          </a:prstGeom>
+          <a:noFill/>
+        </p:spPr>
+        <p:txBody>
+          <a:bodyPr wrap="square">
+            <a:spAutoFit/>
+          </a:bodyPr>
+          <a:lstStyle/>
+          <a:p>
+            <a:pPr algn="l">
+              <a:spcAft>
+                <a:spcPts val="200"/>
+              </a:spcAft>
+            </a:pPr>
+            <a:r>
+              <a:rPr sz="1000" b="0">
+                <a:solidFill>
+                  <a:srgbClr val="333333"/>
+                </a:solidFill>
+              </a:rPr>
+              <a:t>BGE-m3 Embedding이 전체 시간 99% 차지,
+병렬 처리/캐싱 plan 수립</a:t>
+            </a:r>
+          </a:p>
+        </p:txBody>
+      </p:sp>
+      <p:sp>
+        <p:nvSpPr>
+          <p:cNvPr id="85" name="TextBox 84"/>
+          <p:cNvSpPr txBox="1"/>
+          <p:nvPr/>
+        </p:nvSpPr>
+        <p:spPr>
+          <a:xfrm>
+            <a:off x="777240" y="6629400"/>
+            <a:ext cx="365760" cy="274320"/>
+          </a:xfrm>
+          <a:prstGeom prst="rect">
+            <a:avLst/>
+          </a:prstGeom>
+          <a:noFill/>
+        </p:spPr>
+        <p:txBody>
+          <a:bodyPr wrap="square">
+            <a:spAutoFit/>
+          </a:bodyPr>
+          <a:lstStyle/>
+          <a:p>
+            <a:pPr algn="l">
+              <a:spcAft>
+                <a:spcPts val="200"/>
+              </a:spcAft>
+            </a:pPr>
+            <a:r>
+              <a:rPr sz="1000" b="1">
+                <a:solidFill>
+                  <a:srgbClr val="1A1A2E"/>
+                </a:solidFill>
+              </a:rPr>
+              <a:t>11</a:t>
+            </a:r>
+          </a:p>
+        </p:txBody>
+      </p:sp>
+      <p:sp>
+        <p:nvSpPr>
+          <p:cNvPr id="86" name="TextBox 85"/>
+          <p:cNvSpPr txBox="1"/>
+          <p:nvPr/>
+        </p:nvSpPr>
+        <p:spPr>
+          <a:xfrm>
+            <a:off x="1234440" y="6629400"/>
+            <a:ext cx="2743200" cy="274320"/>
+          </a:xfrm>
+          <a:prstGeom prst="rect">
+            <a:avLst/>
+          </a:prstGeom>
+          <a:noFill/>
+        </p:spPr>
+        <p:txBody>
+          <a:bodyPr wrap="square">
+            <a:spAutoFit/>
+          </a:bodyPr>
+          <a:lstStyle/>
+          <a:p>
+            <a:pPr algn="l">
+              <a:spcAft>
+                <a:spcPts val="200"/>
+              </a:spcAft>
+            </a:pPr>
+            <a:r>
+              <a:rPr sz="1000" b="0">
+                <a:solidFill>
+                  <a:srgbClr val="333333"/>
+                </a:solidFill>
+              </a:rPr>
+              <a:t>Ollama 연결 실패</a:t>
+            </a:r>
+          </a:p>
+        </p:txBody>
+      </p:sp>
+      <p:sp>
+        <p:nvSpPr>
+          <p:cNvPr id="87" name="TextBox 86"/>
+          <p:cNvSpPr txBox="1"/>
+          <p:nvPr/>
+        </p:nvSpPr>
+        <p:spPr>
+          <a:xfrm>
+            <a:off x="3794760" y="6629400"/>
+            <a:ext cx="640080" cy="274320"/>
+          </a:xfrm>
+          <a:prstGeom prst="rect">
+            <a:avLst/>
+          </a:prstGeom>
+          <a:noFill/>
+        </p:spPr>
+        <p:txBody>
+          <a:bodyPr wrap="square">
+            <a:spAutoFit/>
+          </a:bodyPr>
+          <a:lstStyle/>
+          <a:p>
+            <a:pPr algn="l">
+              <a:spcAft>
+                <a:spcPts val="200"/>
+              </a:spcAft>
+            </a:pPr>
+            <a:r>
+              <a:rPr sz="1000" b="1">
+                <a:solidFill>
+                  <a:srgbClr val="E88000"/>
+                </a:solidFill>
+              </a:rPr>
+              <a:t>bug</a:t>
+            </a:r>
+          </a:p>
+        </p:txBody>
+      </p:sp>
+      <p:sp>
+        <p:nvSpPr>
+          <p:cNvPr id="88" name="TextBox 87"/>
+          <p:cNvSpPr txBox="1"/>
+          <p:nvPr/>
+        </p:nvSpPr>
+        <p:spPr>
+          <a:xfrm>
+            <a:off x="4526280" y="6629400"/>
+            <a:ext cx="3657600" cy="457200"/>
+          </a:xfrm>
+          <a:prstGeom prst="rect">
+            <a:avLst/>
+          </a:prstGeom>
+          <a:noFill/>
+        </p:spPr>
+        <p:txBody>
+          <a:bodyPr wrap="square">
+            <a:spAutoFit/>
+          </a:bodyPr>
+          <a:lstStyle/>
+          <a:p>
+            <a:pPr algn="l">
+              <a:spcAft>
+                <a:spcPts val="200"/>
+              </a:spcAft>
+            </a:pPr>
+            <a:r>
+              <a:rPr sz="1000" b="0">
+                <a:solidFill>
+                  <a:srgbClr val="333333"/>
+                </a:solidFill>
+              </a:rPr>
+              <a:t>ConnectionRefusedError → Ollama 실행 확인 로직 추가,
+UI에 실행 상태 표시</a:t>
+            </a:r>
+          </a:p>
+        </p:txBody>
+      </p:sp>
+      <p:sp>
+        <p:nvSpPr>
+          <p:cNvPr id="89" name="TextBox 88"/>
+          <p:cNvSpPr txBox="1"/>
+          <p:nvPr/>
+        </p:nvSpPr>
+        <p:spPr>
+          <a:xfrm>
+            <a:off x="777240" y="7086600"/>
+            <a:ext cx="365760" cy="274320"/>
+          </a:xfrm>
+          <a:prstGeom prst="rect">
+            <a:avLst/>
+          </a:prstGeom>
+          <a:noFill/>
+        </p:spPr>
+        <p:txBody>
+          <a:bodyPr wrap="square">
+            <a:spAutoFit/>
+          </a:bodyPr>
+          <a:lstStyle/>
+          <a:p>
+            <a:pPr algn="l">
+              <a:spcAft>
+                <a:spcPts val="200"/>
+              </a:spcAft>
+            </a:pPr>
+            <a:r>
+              <a:rPr sz="1000" b="1">
+                <a:solidFill>
+                  <a:srgbClr val="1A1A2E"/>
+                </a:solidFill>
+              </a:rPr>
+              <a:t>12</a:t>
+            </a:r>
+          </a:p>
+        </p:txBody>
+      </p:sp>
+      <p:sp>
+        <p:nvSpPr>
+          <p:cNvPr id="90" name="TextBox 89"/>
+          <p:cNvSpPr txBox="1"/>
+          <p:nvPr/>
+        </p:nvSpPr>
+        <p:spPr>
+          <a:xfrm>
+            <a:off x="1234440" y="7086600"/>
+            <a:ext cx="2743200" cy="274320"/>
+          </a:xfrm>
+          <a:prstGeom prst="rect">
+            <a:avLst/>
+          </a:prstGeom>
+          <a:noFill/>
+        </p:spPr>
+        <p:txBody>
+          <a:bodyPr wrap="square">
+            <a:spAutoFit/>
+          </a:bodyPr>
+          <a:lstStyle/>
+          <a:p>
+            <a:pPr algn="l">
+              <a:spcAft>
+                <a:spcPts val="200"/>
+              </a:spcAft>
+            </a:pPr>
+            <a:r>
+              <a:rPr sz="1000" b="0">
+                <a:solidFill>
+                  <a:srgbClr val="333333"/>
+                </a:solidFill>
+              </a:rPr>
+              <a:t>Metadata Persistence</a:t>
+            </a:r>
+          </a:p>
+        </p:txBody>
+      </p:sp>
+      <p:sp>
+        <p:nvSpPr>
+          <p:cNvPr id="91" name="TextBox 90"/>
+          <p:cNvSpPr txBox="1"/>
+          <p:nvPr/>
+        </p:nvSpPr>
+        <p:spPr>
+          <a:xfrm>
+            <a:off x="3794760" y="7086600"/>
+            <a:ext cx="640080" cy="274320"/>
+          </a:xfrm>
+          <a:prstGeom prst="rect">
+            <a:avLst/>
+          </a:prstGeom>
+          <a:noFill/>
+        </p:spPr>
+        <p:txBody>
+          <a:bodyPr wrap="square">
+            <a:spAutoFit/>
+          </a:bodyPr>
+          <a:lstStyle/>
+          <a:p>
+            <a:pPr algn="l">
+              <a:spcAft>
+                <a:spcPts val="200"/>
+              </a:spcAft>
+            </a:pPr>
+            <a:r>
+              <a:rPr sz="1000" b="1">
+                <a:solidFill>
+                  <a:srgbClr val="0070C0"/>
+                </a:solidFill>
+              </a:rPr>
+              <a:t>decision</a:t>
+            </a:r>
+          </a:p>
+        </p:txBody>
+      </p:sp>
+      <p:sp>
+        <p:nvSpPr>
+          <p:cNvPr id="92" name="TextBox 91"/>
+          <p:cNvSpPr txBox="1"/>
+          <p:nvPr/>
+        </p:nvSpPr>
+        <p:spPr>
+          <a:xfrm>
+            <a:off x="4526280" y="7086600"/>
+            <a:ext cx="3657600" cy="457200"/>
+          </a:xfrm>
+          <a:prstGeom prst="rect">
+            <a:avLst/>
+          </a:prstGeom>
+          <a:noFill/>
+        </p:spPr>
+        <p:txBody>
+          <a:bodyPr wrap="square">
+            <a:spAutoFit/>
+          </a:bodyPr>
+          <a:lstStyle/>
+          <a:p>
+            <a:pPr algn="l">
+              <a:spcAft>
+                <a:spcPts val="200"/>
+              </a:spcAft>
+            </a:pPr>
+            <a:r>
+              <a:rPr sz="1000" b="0">
+                <a:solidFill>
+                  <a:srgbClr val="333333"/>
+                </a:solidFill>
+              </a:rPr>
+              <a:t>FAISS 재시작 시 ingest 내역 소실 →
+metadata JSON 저장소 도입 (vi/filename/source)</a:t>
+            </a:r>
+          </a:p>
+        </p:txBody>
+      </p:sp>
+      <p:sp>
+        <p:nvSpPr>
+          <p:cNvPr id="93" name="TextBox 92"/>
+          <p:cNvSpPr txBox="1"/>
+          <p:nvPr/>
+        </p:nvSpPr>
+        <p:spPr>
+          <a:xfrm>
+            <a:off x="777240" y="7543800"/>
+            <a:ext cx="365760" cy="274320"/>
+          </a:xfrm>
+          <a:prstGeom prst="rect">
+            <a:avLst/>
+          </a:prstGeom>
+          <a:noFill/>
+        </p:spPr>
+        <p:txBody>
+          <a:bodyPr wrap="square">
+            <a:spAutoFit/>
+          </a:bodyPr>
+          <a:lstStyle/>
+          <a:p>
+            <a:pPr algn="l">
+              <a:spcAft>
+                <a:spcPts val="200"/>
+              </a:spcAft>
+            </a:pPr>
+            <a:r>
+              <a:rPr sz="1000" b="1">
+                <a:solidFill>
+                  <a:srgbClr val="1A1A2E"/>
+                </a:solidFill>
+              </a:rPr>
+              <a:t>13</a:t>
+            </a:r>
+          </a:p>
+        </p:txBody>
+      </p:sp>
+      <p:sp>
+        <p:nvSpPr>
+          <p:cNvPr id="94" name="TextBox 93"/>
+          <p:cNvSpPr txBox="1"/>
+          <p:nvPr/>
+        </p:nvSpPr>
+        <p:spPr>
+          <a:xfrm>
+            <a:off x="1234440" y="7543800"/>
+            <a:ext cx="2743200" cy="274320"/>
+          </a:xfrm>
+          <a:prstGeom prst="rect">
+            <a:avLst/>
+          </a:prstGeom>
+          <a:noFill/>
+        </p:spPr>
+        <p:txBody>
+          <a:bodyPr wrap="square">
+            <a:spAutoFit/>
+          </a:bodyPr>
+          <a:lstStyle/>
+          <a:p>
+            <a:pPr algn="l">
+              <a:spcAft>
+                <a:spcPts val="200"/>
+              </a:spcAft>
+            </a:pPr>
+            <a:r>
+              <a:rPr sz="1000" b="0">
+                <a:solidFill>
+                  <a:srgbClr val="333333"/>
+                </a:solidFill>
+              </a:rPr>
+              <a:t>Harness Engineering</a:t>
+            </a:r>
+          </a:p>
+        </p:txBody>
+      </p:sp>
+      <p:sp>
+        <p:nvSpPr>
+          <p:cNvPr id="95" name="TextBox 94"/>
+          <p:cNvSpPr txBox="1"/>
+          <p:nvPr/>
+        </p:nvSpPr>
+        <p:spPr>
+          <a:xfrm>
+            <a:off x="3794760" y="7543800"/>
+            <a:ext cx="640080" cy="274320"/>
+          </a:xfrm>
+          <a:prstGeom prst="rect">
+            <a:avLst/>
+          </a:prstGeom>
+          <a:noFill/>
+        </p:spPr>
+        <p:txBody>
+          <a:bodyPr wrap="square">
+            <a:spAutoFit/>
+          </a:bodyPr>
+          <a:lstStyle/>
+          <a:p>
+            <a:pPr algn="l">
+              <a:spcAft>
+                <a:spcPts val="200"/>
+              </a:spcAft>
+            </a:pPr>
+            <a:r>
+              <a:rPr sz="1000" b="1">
+                <a:solidFill>
+                  <a:srgbClr val="0070C0"/>
+                </a:solidFill>
+              </a:rPr>
+              <a:t>decision</a:t>
+            </a:r>
+          </a:p>
+        </p:txBody>
+      </p:sp>
+      <p:sp>
+        <p:nvSpPr>
+          <p:cNvPr id="96" name="TextBox 95"/>
+          <p:cNvSpPr txBox="1"/>
+          <p:nvPr/>
+        </p:nvSpPr>
+        <p:spPr>
+          <a:xfrm>
+            <a:off x="4526280" y="7543800"/>
+            <a:ext cx="3657600" cy="457200"/>
+          </a:xfrm>
+          <a:prstGeom prst="rect">
+            <a:avLst/>
+          </a:prstGeom>
+          <a:noFill/>
+        </p:spPr>
+        <p:txBody>
+          <a:bodyPr wrap="square">
+            <a:spAutoFit/>
+          </a:bodyPr>
+          <a:lstStyle/>
+          <a:p>
+            <a:pPr algn="l">
+              <a:spcAft>
+                <a:spcPts val="200"/>
+              </a:spcAft>
+            </a:pPr>
+            <a:r>
+              <a:rPr sz="1000" b="0">
+                <a:solidFill>
+                  <a:srgbClr val="333333"/>
+                </a:solidFill>
+              </a:rPr>
+              <a:t>ruff + pytest + import 검증 harness 구축,
+119 tests pass + ruff clean 유지</a:t>
+            </a:r>
+          </a:p>
+        </p:txBody>
+      </p:sp>
+      <p:sp>
+        <p:nvSpPr>
+          <p:cNvPr id="97" name="TextBox 96"/>
+          <p:cNvSpPr txBox="1"/>
+          <p:nvPr/>
+        </p:nvSpPr>
+        <p:spPr>
+          <a:xfrm>
+            <a:off x="777240" y="8001000"/>
+            <a:ext cx="365760" cy="274320"/>
+          </a:xfrm>
+          <a:prstGeom prst="rect">
+            <a:avLst/>
+          </a:prstGeom>
+          <a:noFill/>
+        </p:spPr>
+        <p:txBody>
+          <a:bodyPr wrap="square">
+            <a:spAutoFit/>
+          </a:bodyPr>
+          <a:lstStyle/>
+          <a:p>
+            <a:pPr algn="l">
+              <a:spcAft>
+                <a:spcPts val="200"/>
+              </a:spcAft>
+            </a:pPr>
+            <a:r>
+              <a:rPr sz="1000" b="1">
+                <a:solidFill>
+                  <a:srgbClr val="1A1A2E"/>
+                </a:solidFill>
+              </a:rPr>
+              <a:t>14</a:t>
+            </a:r>
+          </a:p>
+        </p:txBody>
+      </p:sp>
+      <p:sp>
+        <p:nvSpPr>
+          <p:cNvPr id="98" name="TextBox 97"/>
+          <p:cNvSpPr txBox="1"/>
+          <p:nvPr/>
+        </p:nvSpPr>
+        <p:spPr>
+          <a:xfrm>
+            <a:off x="1234440" y="8001000"/>
+            <a:ext cx="2743200" cy="274320"/>
+          </a:xfrm>
+          <a:prstGeom prst="rect">
+            <a:avLst/>
+          </a:prstGeom>
+          <a:noFill/>
+        </p:spPr>
+        <p:txBody>
+          <a:bodyPr wrap="square">
+            <a:spAutoFit/>
+          </a:bodyPr>
+          <a:lstStyle/>
+          <a:p>
+            <a:pPr algn="l">
+              <a:spcAft>
+                <a:spcPts val="200"/>
+              </a:spcAft>
+            </a:pPr>
+            <a:r>
+              <a:rPr sz="1000" b="0">
+                <a:solidFill>
+                  <a:srgbClr val="333333"/>
+                </a:solidFill>
+              </a:rPr>
+              <a:t>Arxiv Agent 개선</a:t>
+            </a:r>
+          </a:p>
+        </p:txBody>
+      </p:sp>
+      <p:sp>
+        <p:nvSpPr>
+          <p:cNvPr id="99" name="TextBox 98"/>
+          <p:cNvSpPr txBox="1"/>
+          <p:nvPr/>
+        </p:nvSpPr>
+        <p:spPr>
+          <a:xfrm>
+            <a:off x="3794760" y="8001000"/>
+            <a:ext cx="640080" cy="274320"/>
+          </a:xfrm>
+          <a:prstGeom prst="rect">
+            <a:avLst/>
+          </a:prstGeom>
+          <a:noFill/>
+        </p:spPr>
+        <p:txBody>
+          <a:bodyPr wrap="square">
+            <a:spAutoFit/>
+          </a:bodyPr>
+          <a:lstStyle/>
+          <a:p>
+            <a:pPr algn="l">
+              <a:spcAft>
+                <a:spcPts val="200"/>
+              </a:spcAft>
+            </a:pPr>
+            <a:r>
+              <a:rPr sz="1000" b="1">
+                <a:solidFill>
+                  <a:srgbClr val="0070C0"/>
+                </a:solidFill>
+              </a:rPr>
+              <a:t>decision</a:t>
+            </a:r>
+          </a:p>
+        </p:txBody>
+      </p:sp>
+      <p:sp>
+        <p:nvSpPr>
+          <p:cNvPr id="100" name="TextBox 99"/>
+          <p:cNvSpPr txBox="1"/>
+          <p:nvPr/>
+        </p:nvSpPr>
+        <p:spPr>
+          <a:xfrm>
+            <a:off x="4526280" y="8001000"/>
+            <a:ext cx="3657600" cy="457200"/>
+          </a:xfrm>
+          <a:prstGeom prst="rect">
+            <a:avLst/>
+          </a:prstGeom>
+          <a:noFill/>
+        </p:spPr>
+        <p:txBody>
+          <a:bodyPr wrap="square">
+            <a:spAutoFit/>
+          </a:bodyPr>
+          <a:lstStyle/>
+          <a:p>
+            <a:pPr algn="l">
+              <a:spcAft>
+                <a:spcPts val="200"/>
+              </a:spcAft>
+            </a:pPr>
+            <a:r>
+              <a:rPr sz="1000" b="0">
+                <a:solidFill>
+                  <a:srgbClr val="333333"/>
+                </a:solidFill>
+              </a:rPr>
+              <a:t>Query Optimizer Agent + batch summarize +
+rerank + LLM intent classification 도입</a:t>
+            </a:r>
+          </a:p>
+        </p:txBody>
+      </p:sp>
+      <p:sp>
+        <p:nvSpPr>
+          <p:cNvPr id="101" name="TextBox 100"/>
+          <p:cNvSpPr txBox="1"/>
+          <p:nvPr/>
+        </p:nvSpPr>
+        <p:spPr>
+          <a:xfrm>
+            <a:off x="777240" y="8458200"/>
+            <a:ext cx="365760" cy="274320"/>
+          </a:xfrm>
+          <a:prstGeom prst="rect">
+            <a:avLst/>
+          </a:prstGeom>
+          <a:noFill/>
+        </p:spPr>
+        <p:txBody>
+          <a:bodyPr wrap="square">
+            <a:spAutoFit/>
+          </a:bodyPr>
+          <a:lstStyle/>
+          <a:p>
+            <a:pPr algn="l">
+              <a:spcAft>
+                <a:spcPts val="200"/>
+              </a:spcAft>
+            </a:pPr>
+            <a:r>
+              <a:rPr sz="1000" b="1">
+                <a:solidFill>
+                  <a:srgbClr val="1A1A2E"/>
+                </a:solidFill>
+              </a:rPr>
+              <a:t>15</a:t>
+            </a:r>
+          </a:p>
+        </p:txBody>
+      </p:sp>
+      <p:sp>
+        <p:nvSpPr>
+          <p:cNvPr id="102" name="TextBox 101"/>
+          <p:cNvSpPr txBox="1"/>
+          <p:nvPr/>
+        </p:nvSpPr>
+        <p:spPr>
+          <a:xfrm>
+            <a:off x="1234440" y="8458200"/>
+            <a:ext cx="2743200" cy="274320"/>
+          </a:xfrm>
+          <a:prstGeom prst="rect">
+            <a:avLst/>
+          </a:prstGeom>
+          <a:noFill/>
+        </p:spPr>
+        <p:txBody>
+          <a:bodyPr wrap="square">
+            <a:spAutoFit/>
+          </a:bodyPr>
+          <a:lstStyle/>
+          <a:p>
+            <a:pPr algn="l">
+              <a:spcAft>
+                <a:spcPts val="200"/>
+              </a:spcAft>
+            </a:pPr>
+            <a:r>
+              <a:rPr sz="1000" b="0">
+                <a:solidFill>
+                  <a:srgbClr val="333333"/>
+                </a:solidFill>
+              </a:rPr>
+              <a:t>Paper Agent RAG 고도화</a:t>
+            </a:r>
+          </a:p>
+        </p:txBody>
+      </p:sp>
+      <p:sp>
+        <p:nvSpPr>
+          <p:cNvPr id="103" name="TextBox 102"/>
+          <p:cNvSpPr txBox="1"/>
+          <p:nvPr/>
+        </p:nvSpPr>
+        <p:spPr>
+          <a:xfrm>
+            <a:off x="3794760" y="8458200"/>
+            <a:ext cx="640080" cy="274320"/>
+          </a:xfrm>
+          <a:prstGeom prst="rect">
+            <a:avLst/>
+          </a:prstGeom>
+          <a:noFill/>
+        </p:spPr>
+        <p:txBody>
+          <a:bodyPr wrap="square">
+            <a:spAutoFit/>
+          </a:bodyPr>
+          <a:lstStyle/>
+          <a:p>
+            <a:pPr algn="l">
+              <a:spcAft>
+                <a:spcPts val="200"/>
+              </a:spcAft>
+            </a:pPr>
+            <a:r>
+              <a:rPr sz="1000" b="1">
+                <a:solidFill>
+                  <a:srgbClr val="0070C0"/>
+                </a:solidFill>
+              </a:rPr>
+              <a:t>decision</a:t>
+            </a:r>
+          </a:p>
+        </p:txBody>
+      </p:sp>
+      <p:sp>
+        <p:nvSpPr>
+          <p:cNvPr id="104" name="TextBox 103"/>
+          <p:cNvSpPr txBox="1"/>
+          <p:nvPr/>
+        </p:nvSpPr>
+        <p:spPr>
+          <a:xfrm>
+            <a:off x="4526280" y="8458200"/>
+            <a:ext cx="3657600" cy="457200"/>
+          </a:xfrm>
+          <a:prstGeom prst="rect">
+            <a:avLst/>
+          </a:prstGeom>
+          <a:noFill/>
+        </p:spPr>
+        <p:txBody>
+          <a:bodyPr wrap="square">
+            <a:spAutoFit/>
+          </a:bodyPr>
+          <a:lstStyle/>
+          <a:p>
+            <a:pPr algn="l">
+              <a:spcAft>
+                <a:spcPts val="200"/>
+              </a:spcAft>
+            </a:pPr>
+            <a:r>
+              <a:rPr sz="1000" b="0">
+                <a:solidFill>
+                  <a:srgbClr val="333333"/>
+                </a:solidFill>
+              </a:rPr>
+              <a:t>Phase 0-5: Semantic Chunking → Query Rewrite
+→ Multi-Strategy → Academic Prompt → Verify → Analyst</a:t>
+            </a:r>
+          </a:p>
+        </p:txBody>
+      </p:sp>
+      <p:sp>
+        <p:nvSpPr>
+          <p:cNvPr id="105" name="TextBox 104"/>
+          <p:cNvSpPr txBox="1"/>
+          <p:nvPr/>
+        </p:nvSpPr>
+        <p:spPr>
+          <a:xfrm>
+            <a:off x="777240" y="8915400"/>
+            <a:ext cx="365760" cy="274320"/>
+          </a:xfrm>
+          <a:prstGeom prst="rect">
+            <a:avLst/>
+          </a:prstGeom>
+          <a:noFill/>
+        </p:spPr>
+        <p:txBody>
+          <a:bodyPr wrap="square">
+            <a:spAutoFit/>
+          </a:bodyPr>
+          <a:lstStyle/>
+          <a:p>
+            <a:pPr algn="l">
+              <a:spcAft>
+                <a:spcPts val="200"/>
+              </a:spcAft>
+            </a:pPr>
+            <a:r>
+              <a:rPr sz="1000" b="1">
+                <a:solidFill>
+                  <a:srgbClr val="1A1A2E"/>
+                </a:solidFill>
+              </a:rPr>
+              <a:t>16</a:t>
+            </a:r>
+          </a:p>
+        </p:txBody>
+      </p:sp>
+      <p:sp>
+        <p:nvSpPr>
+          <p:cNvPr id="106" name="TextBox 105"/>
+          <p:cNvSpPr txBox="1"/>
+          <p:nvPr/>
+        </p:nvSpPr>
+        <p:spPr>
+          <a:xfrm>
+            <a:off x="1234440" y="8915400"/>
+            <a:ext cx="2743200" cy="274320"/>
+          </a:xfrm>
+          <a:prstGeom prst="rect">
+            <a:avLst/>
+          </a:prstGeom>
+          <a:noFill/>
+        </p:spPr>
+        <p:txBody>
+          <a:bodyPr wrap="square">
+            <a:spAutoFit/>
+          </a:bodyPr>
+          <a:lstStyle/>
+          <a:p>
+            <a:pPr algn="l">
+              <a:spcAft>
+                <a:spcPts val="200"/>
+              </a:spcAft>
+            </a:pPr>
+            <a:r>
+              <a:rPr sz="1000" b="0">
+                <a:solidFill>
+                  <a:srgbClr val="333333"/>
+                </a:solidFill>
+              </a:rPr>
+              <a:t>Keyword→LLM 분류 전환</a:t>
+            </a:r>
+          </a:p>
+        </p:txBody>
+      </p:sp>
+      <p:sp>
+        <p:nvSpPr>
+          <p:cNvPr id="107" name="TextBox 106"/>
+          <p:cNvSpPr txBox="1"/>
+          <p:nvPr/>
+        </p:nvSpPr>
+        <p:spPr>
+          <a:xfrm>
+            <a:off x="3794760" y="8915400"/>
+            <a:ext cx="640080" cy="274320"/>
+          </a:xfrm>
+          <a:prstGeom prst="rect">
+            <a:avLst/>
+          </a:prstGeom>
+          <a:noFill/>
+        </p:spPr>
+        <p:txBody>
+          <a:bodyPr wrap="square">
+            <a:spAutoFit/>
+          </a:bodyPr>
+          <a:lstStyle/>
+          <a:p>
+            <a:pPr algn="l">
+              <a:spcAft>
+                <a:spcPts val="200"/>
+              </a:spcAft>
+            </a:pPr>
+            <a:r>
+              <a:rPr sz="1000" b="1">
+                <a:solidFill>
+                  <a:srgbClr val="0070C0"/>
+                </a:solidFill>
+              </a:rPr>
+              <a:t>decision</a:t>
+            </a:r>
+          </a:p>
+        </p:txBody>
+      </p:sp>
+      <p:sp>
+        <p:nvSpPr>
+          <p:cNvPr id="108" name="TextBox 107"/>
+          <p:cNvSpPr txBox="1"/>
+          <p:nvPr/>
+        </p:nvSpPr>
+        <p:spPr>
+          <a:xfrm>
+            <a:off x="4526280" y="8915400"/>
+            <a:ext cx="3657600" cy="457200"/>
+          </a:xfrm>
+          <a:prstGeom prst="rect">
+            <a:avLst/>
+          </a:prstGeom>
+          <a:noFill/>
+        </p:spPr>
+        <p:txBody>
+          <a:bodyPr wrap="square">
+            <a:spAutoFit/>
+          </a:bodyPr>
+          <a:lstStyle/>
+          <a:p>
+            <a:pPr algn="l">
+              <a:spcAft>
+                <a:spcPts val="200"/>
+              </a:spcAft>
+            </a:pPr>
+            <a:r>
+              <a:rPr sz="1000" b="0">
+                <a:solidFill>
+                  <a:srgbClr val="333333"/>
+                </a:solidFill>
+              </a:rPr>
+              <a:t>rule-based intent → Ollama few-shot LLM,
+temperature=0.0으로 결정적 출력 보장</a:t>
             </a:r>
           </a:p>
         </p:txBody>

</xml_diff>